<commit_message>
submission: deck with new-UI screenshots
</commit_message>
<xml_diff>
--- a/submission/Setu_Deck.pptx
+++ b/submission/Setu_Deck.pptx
@@ -4,9 +4,6 @@
   <p:sldMasterIdLst>
     <p:sldMasterId id="2147483648" r:id="rId1"/>
   </p:sldMasterIdLst>
-  <p:notesMasterIdLst>
-    <p:notesMasterId r:id="rId14"/>
-  </p:notesMasterIdLst>
   <p:sldIdLst>
     <p:sldId id="256" r:id="rId2"/>
     <p:sldId id="257" r:id="rId3"/>
@@ -21,6 +18,9 @@
     <p:sldId id="266" r:id="rId12"/>
     <p:sldId id="267" r:id="rId13"/>
   </p:sldIdLst>
+  <p:notesMasterIdLst>
+    <p:notesMasterId r:id="rId14"/>
+  </p:notesMasterIdLst>
   <p:sldSz cx="12192000" cy="6858000"/>
   <p:notesSz cx="6858000" cy="12192000"/>
   <p:defaultTextStyle>
@@ -1948,6 +1948,9 @@
               </a:rPr>
               <a:t>Setu </a:t>
             </a:r>
+            <a:pPr indent="0" marL="0">
+              <a:buNone/>
+            </a:pPr>
             <a:r>
               <a:rPr lang="en-US" sz="8800" b="1" dirty="0">
                 <a:solidFill>
@@ -2037,6 +2040,9 @@
               </a:rPr>
               <a:t>Reads the fee notice, explains it in English or </a:t>
             </a:r>
+            <a:pPr indent="0" marL="0">
+              <a:buNone/>
+            </a:pPr>
             <a:r>
               <a:rPr lang="en-US" sz="1600" dirty="0">
                 <a:solidFill>
@@ -2048,6 +2054,9 @@
               </a:rPr>
               <a:t>简体中文</a:t>
             </a:r>
+            <a:pPr indent="0" marL="0">
+              <a:buNone/>
+            </a:pPr>
             <a:r>
               <a:rPr lang="en-US" sz="1600" dirty="0">
                 <a:solidFill>
@@ -2160,6 +2169,9 @@
               </a:rPr>
               <a:t>Setu </a:t>
             </a:r>
+            <a:pPr indent="0" marL="0">
+              <a:buNone/>
+            </a:pPr>
             <a:r>
               <a:rPr lang="en-US" sz="1000" dirty="0">
                 <a:solidFill>
@@ -2171,6 +2183,9 @@
               </a:rPr>
               <a:t>桥</a:t>
             </a:r>
+            <a:pPr indent="0" marL="0">
+              <a:buNone/>
+            </a:pPr>
             <a:r>
               <a:rPr lang="en-US" sz="1000" dirty="0">
                 <a:solidFill>
@@ -2957,6 +2972,9 @@
               </a:rPr>
               <a:t>Reproduce:  </a:t>
             </a:r>
+            <a:pPr indent="0" marL="0">
+              <a:buNone/>
+            </a:pPr>
             <a:r>
               <a:rPr lang="en-US" sz="1300" dirty="0">
                 <a:solidFill>
@@ -2968,6 +2986,9 @@
               </a:rPr>
               <a:t>make install &amp;&amp; make evidence</a:t>
             </a:r>
+            <a:pPr indent="0" marL="0">
+              <a:buNone/>
+            </a:pPr>
             <a:r>
               <a:rPr lang="en-US" sz="1300" dirty="0">
                 <a:solidFill>
@@ -3018,6 +3039,9 @@
               </a:rPr>
               <a:t>Setu </a:t>
             </a:r>
+            <a:pPr indent="0" marL="0">
+              <a:buNone/>
+            </a:pPr>
             <a:r>
               <a:rPr lang="en-US" sz="1000" dirty="0">
                 <a:solidFill>
@@ -3029,6 +3053,9 @@
               </a:rPr>
               <a:t>桥</a:t>
             </a:r>
+            <a:pPr indent="0" marL="0">
+              <a:buNone/>
+            </a:pPr>
             <a:r>
               <a:rPr lang="en-US" sz="1000" dirty="0">
                 <a:solidFill>
@@ -3277,6 +3304,7 @@
               <a:spcAft>
                 <a:spcPts val="800"/>
               </a:spcAft>
+              <a:buSzPct val="100000"/>
               <a:buChar char="•"/>
             </a:pPr>
             <a:r>
@@ -3297,6 +3325,7 @@
               <a:spcAft>
                 <a:spcPts val="800"/>
               </a:spcAft>
+              <a:buSzPct val="100000"/>
               <a:buChar char="•"/>
             </a:pPr>
             <a:r>
@@ -3317,6 +3346,7 @@
               <a:spcAft>
                 <a:spcPts val="800"/>
               </a:spcAft>
+              <a:buSzPct val="100000"/>
               <a:buChar char="•"/>
             </a:pPr>
             <a:r>
@@ -3337,6 +3367,7 @@
               <a:spcAft>
                 <a:spcPts val="800"/>
               </a:spcAft>
+              <a:buSzPct val="100000"/>
               <a:buChar char="•"/>
             </a:pPr>
             <a:r>
@@ -3357,6 +3388,7 @@
               <a:spcAft>
                 <a:spcPts val="800"/>
               </a:spcAft>
+              <a:buSzPct val="100000"/>
               <a:buChar char="•"/>
             </a:pPr>
             <a:r>
@@ -3377,6 +3409,7 @@
               <a:spcAft>
                 <a:spcPts val="800"/>
               </a:spcAft>
+              <a:buSzPct val="100000"/>
               <a:buChar char="•"/>
             </a:pPr>
             <a:r>
@@ -3517,6 +3550,7 @@
               <a:spcAft>
                 <a:spcPts val="800"/>
               </a:spcAft>
+              <a:buSzPct val="100000"/>
               <a:buChar char="•"/>
             </a:pPr>
             <a:r>
@@ -3537,6 +3571,7 @@
               <a:spcAft>
                 <a:spcPts val="800"/>
               </a:spcAft>
+              <a:buSzPct val="100000"/>
               <a:buChar char="•"/>
             </a:pPr>
             <a:r>
@@ -3557,6 +3592,7 @@
               <a:spcAft>
                 <a:spcPts val="800"/>
               </a:spcAft>
+              <a:buSzPct val="100000"/>
               <a:buChar char="•"/>
             </a:pPr>
             <a:r>
@@ -3577,6 +3613,7 @@
               <a:spcAft>
                 <a:spcPts val="800"/>
               </a:spcAft>
+              <a:buSzPct val="100000"/>
               <a:buChar char="•"/>
             </a:pPr>
             <a:r>
@@ -3717,6 +3754,7 @@
               <a:spcAft>
                 <a:spcPts val="800"/>
               </a:spcAft>
+              <a:buSzPct val="100000"/>
               <a:buChar char="•"/>
             </a:pPr>
             <a:r>
@@ -3737,6 +3775,7 @@
               <a:spcAft>
                 <a:spcPts val="800"/>
               </a:spcAft>
+              <a:buSzPct val="100000"/>
               <a:buChar char="•"/>
             </a:pPr>
             <a:r>
@@ -3757,6 +3796,7 @@
               <a:spcAft>
                 <a:spcPts val="800"/>
               </a:spcAft>
+              <a:buSzPct val="100000"/>
               <a:buChar char="•"/>
             </a:pPr>
             <a:r>
@@ -3777,6 +3817,7 @@
               <a:spcAft>
                 <a:spcPts val="800"/>
               </a:spcAft>
+              <a:buSzPct val="100000"/>
               <a:buChar char="•"/>
             </a:pPr>
             <a:r>
@@ -3797,6 +3838,7 @@
               <a:spcAft>
                 <a:spcPts val="800"/>
               </a:spcAft>
+              <a:buSzPct val="100000"/>
               <a:buChar char="•"/>
             </a:pPr>
             <a:r>
@@ -3849,6 +3891,9 @@
               </a:rPr>
               <a:t>Setu </a:t>
             </a:r>
+            <a:pPr indent="0" marL="0">
+              <a:buNone/>
+            </a:pPr>
             <a:r>
               <a:rPr lang="en-US" sz="1000" dirty="0">
                 <a:solidFill>
@@ -3860,6 +3905,9 @@
               </a:rPr>
               <a:t>桥</a:t>
             </a:r>
+            <a:pPr indent="0" marL="0">
+              <a:buNone/>
+            </a:pPr>
             <a:r>
               <a:rPr lang="en-US" sz="1000" dirty="0">
                 <a:solidFill>
@@ -4102,6 +4150,9 @@
               </a:rPr>
               <a:t>Try it offline, no keys:  </a:t>
             </a:r>
+            <a:pPr indent="0" marL="0">
+              <a:buNone/>
+            </a:pPr>
             <a:r>
               <a:rPr lang="en-US" sz="1600" dirty="0">
                 <a:solidFill>
@@ -4230,6 +4281,9 @@
               </a:rPr>
               <a:t>Setu </a:t>
             </a:r>
+            <a:pPr indent="0" marL="0">
+              <a:buNone/>
+            </a:pPr>
             <a:r>
               <a:rPr lang="en-US" sz="1000" dirty="0">
                 <a:solidFill>
@@ -4241,6 +4295,9 @@
               </a:rPr>
               <a:t>桥</a:t>
             </a:r>
+            <a:pPr indent="0" marL="0">
+              <a:buNone/>
+            </a:pPr>
             <a:r>
               <a:rPr lang="en-US" sz="1000" dirty="0">
                 <a:solidFill>
@@ -5008,6 +5065,9 @@
               </a:rPr>
               <a:t>Setu </a:t>
             </a:r>
+            <a:pPr indent="0" marL="0">
+              <a:buNone/>
+            </a:pPr>
             <a:r>
               <a:rPr lang="en-US" sz="1000" dirty="0">
                 <a:solidFill>
@@ -5019,6 +5079,9 @@
               </a:rPr>
               <a:t>桥</a:t>
             </a:r>
+            <a:pPr indent="0" marL="0">
+              <a:buNone/>
+            </a:pPr>
             <a:r>
               <a:rPr lang="en-US" sz="1000" dirty="0">
                 <a:solidFill>
@@ -5998,6 +6061,9 @@
               </a:rPr>
               <a:t>Setu </a:t>
             </a:r>
+            <a:pPr indent="0" marL="0">
+              <a:buNone/>
+            </a:pPr>
             <a:r>
               <a:rPr lang="en-US" sz="1000" dirty="0">
                 <a:solidFill>
@@ -6009,6 +6075,9 @@
               </a:rPr>
               <a:t>桥</a:t>
             </a:r>
+            <a:pPr indent="0" marL="0">
+              <a:buNone/>
+            </a:pPr>
             <a:r>
               <a:rPr lang="en-US" sz="1000" dirty="0">
                 <a:solidFill>
@@ -7408,6 +7477,9 @@
               </a:rPr>
               <a:t>Setu </a:t>
             </a:r>
+            <a:pPr indent="0" marL="0">
+              <a:buNone/>
+            </a:pPr>
             <a:r>
               <a:rPr lang="en-US" sz="1000" dirty="0">
                 <a:solidFill>
@@ -7419,6 +7491,9 @@
               </a:rPr>
               <a:t>桥</a:t>
             </a:r>
+            <a:pPr indent="0" marL="0">
+              <a:buNone/>
+            </a:pPr>
             <a:r>
               <a:rPr lang="en-US" sz="1000" dirty="0">
                 <a:solidFill>
@@ -9202,6 +9277,9 @@
               </a:rPr>
               <a:t>Setu </a:t>
             </a:r>
+            <a:pPr indent="0" marL="0">
+              <a:buNone/>
+            </a:pPr>
             <a:r>
               <a:rPr lang="en-US" sz="1000" dirty="0">
                 <a:solidFill>
@@ -9213,6 +9291,9 @@
               </a:rPr>
               <a:t>桥</a:t>
             </a:r>
+            <a:pPr indent="0" marL="0">
+              <a:buNone/>
+            </a:pPr>
             <a:r>
               <a:rPr lang="en-US" sz="1000" dirty="0">
                 <a:solidFill>
@@ -9961,6 +10042,9 @@
               </a:rPr>
               <a:t>Setu </a:t>
             </a:r>
+            <a:pPr indent="0" marL="0">
+              <a:buNone/>
+            </a:pPr>
             <a:r>
               <a:rPr lang="en-US" sz="1000" dirty="0">
                 <a:solidFill>
@@ -9972,6 +10056,9 @@
               </a:rPr>
               <a:t>桥</a:t>
             </a:r>
+            <a:pPr indent="0" marL="0">
+              <a:buNone/>
+            </a:pPr>
             <a:r>
               <a:rPr lang="en-US" sz="1000" dirty="0">
                 <a:solidFill>
@@ -10976,6 +11063,9 @@
               </a:rPr>
               <a:t>Setu </a:t>
             </a:r>
+            <a:pPr indent="0" marL="0">
+              <a:buNone/>
+            </a:pPr>
             <a:r>
               <a:rPr lang="en-US" sz="1000" dirty="0">
                 <a:solidFill>
@@ -10987,6 +11077,9 @@
               </a:rPr>
               <a:t>桥</a:t>
             </a:r>
+            <a:pPr indent="0" marL="0">
+              <a:buNone/>
+            </a:pPr>
             <a:r>
               <a:rPr lang="en-US" sz="1000" dirty="0">
                 <a:solidFill>
@@ -11554,6 +11647,9 @@
               </a:rPr>
               <a:t>Setu </a:t>
             </a:r>
+            <a:pPr indent="0" marL="0">
+              <a:buNone/>
+            </a:pPr>
             <a:r>
               <a:rPr lang="en-US" sz="1000" dirty="0">
                 <a:solidFill>
@@ -11565,6 +11661,9 @@
               </a:rPr>
               <a:t>桥</a:t>
             </a:r>
+            <a:pPr indent="0" marL="0">
+              <a:buNone/>
+            </a:pPr>
             <a:r>
               <a:rPr lang="en-US" sz="1000" dirty="0">
                 <a:solidFill>
@@ -11876,6 +11975,9 @@
               </a:rPr>
               <a:t>Before: </a:t>
             </a:r>
+            <a:pPr indent="0" marL="0">
+              <a:buNone/>
+            </a:pPr>
             <a:r>
               <a:rPr lang="en-US" sz="1400" dirty="0">
                 <a:solidFill>
@@ -11926,6 +12028,9 @@
               </a:rPr>
               <a:t>After a simulated DB edit: </a:t>
             </a:r>
+            <a:pPr indent="0" marL="0">
+              <a:buNone/>
+            </a:pPr>
             <a:r>
               <a:rPr lang="en-US" sz="1400" dirty="0">
                 <a:solidFill>
@@ -12015,6 +12120,9 @@
               </a:rPr>
               <a:t>Setu </a:t>
             </a:r>
+            <a:pPr indent="0" marL="0">
+              <a:buNone/>
+            </a:pPr>
             <a:r>
               <a:rPr lang="en-US" sz="1000" dirty="0">
                 <a:solidFill>
@@ -12026,6 +12134,9 @@
               </a:rPr>
               <a:t>桥</a:t>
             </a:r>
+            <a:pPr indent="0" marL="0">
+              <a:buNone/>
+            </a:pPr>
             <a:r>
               <a:rPr lang="en-US" sz="1000" dirty="0">
                 <a:solidFill>

</xml_diff>

<commit_message>
video: 1080p full-frame re-record (3:03, burned-in subs, team card); official docx/pptx + deck screenshots and stats refreshed
</commit_message>
<xml_diff>
--- a/submission/Setu_Deck.pptx
+++ b/submission/Setu_Deck.pptx
@@ -601,7 +601,7 @@
           <a:p>
             <a:r>
               <a:rPr lang="en-US" dirty="0"/>
-              <a:t>Sources: evidence/security_report.md (Result: 17/17 attacks blocked), evidence/eval_report.md (25/25 tasks passed; corpus 33/33 verdicts and 33/33 field parsing), server test run `npx vitest run` → Test Files 22 passed, Tests 507 passed (re-run 18 Oct 2026). All offline, scripted planner, SAMPLE FX fixture, SYNTHETIC data.</a:t>
+              <a:t>Sources: evidence/security_report.md (Result: 17/17 attacks blocked), evidence/eval_report.md (25/25 tasks passed; corpus 33/33 verdicts and 33/33 field parsing), server test run `npx vitest run` → Test Files 24 passed, Tests 524 passed (re-run 19 Oct 2026). All offline, scripted planner, SAMPLE FX fixture, SYNTHETIC data.</a:t>
             </a:r>
             <a:endParaRPr lang="en-US" dirty="0"/>
           </a:p>
@@ -2663,7 +2663,7 @@
                 <a:ea typeface="Space Grotesk" pitchFamily="34" charset="-122"/>
                 <a:cs typeface="Space Grotesk" pitchFamily="34" charset="-120"/>
               </a:rPr>
-              <a:t>507</a:t>
+              <a:t>524</a:t>
             </a:r>
             <a:endParaRPr lang="en-US" sz="6000" dirty="0"/>
           </a:p>
@@ -2764,7 +2764,7 @@
                 <a:ea typeface="Inter" pitchFamily="34" charset="-122"/>
                 <a:cs typeface="Inter" pitchFamily="34" charset="-120"/>
               </a:rPr>
-              <a:t>unit, API, golden, security and Python-parity tests (vitest, 22 files)</a:t>
+              <a:t>unit, API, golden, security and Python-parity tests (vitest, 24 files)</a:t>
             </a:r>
             <a:endParaRPr lang="en-US" sz="1200" dirty="0"/>
           </a:p>

</xml_diff>